<commit_message>
Variant 3: swap the open Graph slot for videographer Асанов; retitle Жанабеков
In variant 3, replace the empty Graph position with Асанов Әділ Асанұлы
(Видеограф/видеомонтажер, 1 000 162 ₸) and rename Жанабеков's box from
«Мобилограф / монтажёр Sport» to «Видеограф Sport». Продакшн is now
11 086 553 ₸; grand total 39 218 833 ₸ (34 people). Adds an OVERRIDE_FILE
env to make_xlsx.py for per-field overrides (build/v3_overrides.json).

Co-Authored-By: Claude Opus 4.8 <noreply@anthropic.com>
Claude-Session: https://claude.ai/code/session_015FvdqNtbbJPjugTChUgZkw
</commit_message>
<xml_diff>
--- a/Структура маркетинга — вариант 3.pptx
+++ b/Структура маркетинга — вариант 3.pptx
@@ -2070,7 +2070,7 @@
                 <a:ea typeface="Arial" pitchFamily="34" charset="-122"/>
                 <a:cs typeface="Arial" pitchFamily="34" charset="-120"/>
               </a:rPr>
-              <a:t>11 026 391 ₸</a:t>
+              <a:t>11 086 553 ₸</a:t>
             </a:r>
             <a:endParaRPr lang="en-US" sz="1200" dirty="0"/>
           </a:p>
@@ -2396,7 +2396,7 @@
                 <a:ea typeface="Arial" pitchFamily="34" charset="-122"/>
                 <a:cs typeface="Arial" pitchFamily="34" charset="-120"/>
               </a:rPr>
-              <a:t>39 158 671 ₸</a:t>
+              <a:t>39 218 833 ₸</a:t>
             </a:r>
             <a:endParaRPr lang="en-US" sz="2600" dirty="0"/>
           </a:p>
@@ -5903,7 +5903,7 @@
                 <a:ea typeface="Arial" pitchFamily="34" charset="-122"/>
                 <a:cs typeface="Arial" pitchFamily="34" charset="-120"/>
               </a:rPr>
-              <a:t>11 026 391 ₸</a:t>
+              <a:t>11 086 553 ₸</a:t>
             </a:r>
             <a:endParaRPr lang="en-US" sz="1900" dirty="0"/>
           </a:p>
@@ -6957,7 +6957,7 @@
                 <a:ea typeface="Arial" pitchFamily="34" charset="-122"/>
                 <a:cs typeface="Arial" pitchFamily="34" charset="-120"/>
               </a:rPr>
-              <a:t>Graph</a:t>
+              <a:t>Видеограф/видеомонтажер</a:t>
             </a:r>
             <a:endParaRPr lang="en-US" sz="998" dirty="0"/>
           </a:p>
@@ -6968,6 +6968,17 @@
               </a:lnSpc>
               <a:buNone/>
             </a:pPr>
+            <a:r>
+              <a:rPr lang="en-US" sz="760" i="1" dirty="0">
+                <a:solidFill>
+                  <a:srgbClr val="5B6B7C"/>
+                </a:solidFill>
+                <a:latin typeface="Arial" pitchFamily="34" charset="0"/>
+                <a:ea typeface="Arial" pitchFamily="34" charset="-122"/>
+                <a:cs typeface="Arial" pitchFamily="34" charset="-120"/>
+              </a:rPr>
+              <a:t>Асанов Әділ Асанұлы</a:t>
+            </a:r>
             <a:endParaRPr lang="en-US" sz="998" dirty="0"/>
           </a:p>
           <a:p>
@@ -6980,13 +6991,13 @@
             <a:r>
               <a:rPr lang="en-US" sz="1045" b="1" dirty="0">
                 <a:solidFill>
-                  <a:srgbClr val="B45309"/>
-                </a:solidFill>
-                <a:latin typeface="Arial" pitchFamily="34" charset="0"/>
-                <a:ea typeface="Arial" pitchFamily="34" charset="-122"/>
-                <a:cs typeface="Arial" pitchFamily="34" charset="-120"/>
-              </a:rPr>
-              <a:t>940 000 ₸  *</a:t>
+                  <a:srgbClr val="0F6E4F"/>
+                </a:solidFill>
+                <a:latin typeface="Arial" pitchFamily="34" charset="0"/>
+                <a:ea typeface="Arial" pitchFamily="34" charset="-122"/>
+                <a:cs typeface="Arial" pitchFamily="34" charset="-120"/>
+              </a:rPr>
+              <a:t>1 000 162 ₸</a:t>
             </a:r>
             <a:endParaRPr lang="en-US" sz="998" dirty="0"/>
           </a:p>
@@ -7201,7 +7212,7 @@
                 <a:ea typeface="Arial" pitchFamily="34" charset="-122"/>
                 <a:cs typeface="Arial" pitchFamily="34" charset="-120"/>
               </a:rPr>
-              <a:t>Мобилограф / монтажёр Sport</a:t>
+              <a:t>Видеограф Sport</a:t>
             </a:r>
             <a:endParaRPr lang="en-US" sz="1050" dirty="0"/>
           </a:p>
@@ -9132,7 +9143,7 @@
                 <a:ea typeface="Arial" pitchFamily="34" charset="-122"/>
                 <a:cs typeface="Arial" pitchFamily="34" charset="-120"/>
               </a:rPr>
-              <a:t>ФОТ отдела = сумма должностных окладов (тотал) всех позиций отдела, включая руководителя. Суммы взяты из Excel; руководители и senior-роли — из отдельного блока стоимостей. Итог по 4 отделам: 39 158 671 ₸ в месяц.</a:t>
+              <a:t>ФОТ отдела = сумма должностных окладов (тотал) всех позиций отдела, включая руководителя. Суммы взяты из Excel; руководители и senior-роли — из отдельного блока стоимостей. Итог по 4 отделам: 39 218 833 ₸ в месяц.</a:t>
             </a:r>
             <a:endParaRPr lang="en-US" sz="1200" dirty="0"/>
           </a:p>

</xml_diff>